<commit_message>
Parts net profit band: why expenses rose (basics), P&A expense lines pulled
Co-Authored-By: Claude Opus 5.5 <noreply@anthropic.com>
Claude-Session: https://claude.ai/code/session_01Xa4nFVxuQGXmHARGph9WhS
</commit_message>
<xml_diff>
--- a/day2-deck/decks/Service and Parts Net Profit - House Style.pptx
+++ b/day2-deck/decks/Service and Parts Net Profit - House Style.pptx
@@ -19395,7 +19395,7 @@
           <a:p>
             <a:r>
               <a:rPr lang="en-US" dirty="0"/>
-              <a:t>Source: Qlik - Profit &amp; Loss, Detail statement. Same-store, INEOS excluded (opened 2026). Parts net profit = P&amp;A department profit: department gross less the department's own expenses; GMC Prescott body shop is its own department and is not included. Jan-Sep 2026 vs Jan-Sep 2025; 2025 shown January-December. Store rows reconcile to the group, both years.</a:t>
+              <a:t>Source: Qlik - Profit &amp; Loss, Detail statement. Same-store, INEOS excluded (opened 2026). Parts net profit = P&amp;A department profit: department gross less the department's own expenses; GMC Prescott body shop is its own department and is not included. Jan-Sep 2026 vs Jan-Sep 2025; 2025 shown January-December. Store rows reconcile to the group, both years. P&amp;A department expenses Jan-Sep, 2025 to 2026 (P&amp;L Detail): total total expenses $38,194,373 to $39,174,787; personnel total personnel expense $22,779,551 to $22,353,382; outside services outside services (other) $2,463,996 to $2,954,466; IT services info. technology services $1,758,912 to $2,238,264; advertising advertising $2,046,030 to $1,963,261; advertising rebates (a credit) -$680,064 to -$281,952; rent rent $3,837,561 to $3,938,417.</a:t>
             </a:r>
             <a:endParaRPr lang="en-US" dirty="0"/>
           </a:p>
@@ -43066,7 +43066,7 @@
         <p:spPr>
           <a:xfrm>
             <a:off x="457200" y="6126480"/>
-            <a:ext cx="11274552" cy="371856"/>
+            <a:ext cx="11274552" cy="615696"/>
           </a:xfrm>
           <a:prstGeom prst="rect">
             <a:avLst/>
@@ -43086,7 +43086,7 @@
         <p:spPr>
           <a:xfrm>
             <a:off x="658368" y="6144768"/>
-            <a:ext cx="10927080" cy="335280"/>
+            <a:ext cx="10927080" cy="579120"/>
           </a:xfrm>
           <a:prstGeom prst="rect">
             <a:avLst/>
@@ -43110,7 +43110,7 @@
                 <a:ea typeface="Inter" pitchFamily="34" charset="-122"/>
                 <a:cs typeface="Inter" pitchFamily="34" charset="-120"/>
               </a:rPr>
-              <a:t>+$191K (+0.8%) year to date; 6 of nine months ahead of 2025, largest gain in September, +$506K.</a:t>
+              <a:t>Gross grew 1.9%, expenses 2.6%. People costs went down; outside services, IT and smaller advertising rebates pushed expenses up.</a:t>
             </a:r>
             <a:endParaRPr lang="en-US" sz="1600" dirty="0"/>
           </a:p>

</xml_diff>